<commit_message>
Sync deck speaker-note section references with renumbered study
The sixfold-grammar split shifted study §§7.4-7.7 to §§7.5-7.8; updates the affected [Sources] blocks in the deck notes pane (slides 17-20, 24) and regenerates the slides and read-aloud notes PDFs in order.

Co-authored-by: Raghava Mohan Madhwapathi <raghavamohan@users.noreply.github.com>
</commit_message>
<xml_diff>
--- a/Studies/A-State-Dynamic-Model-Of-Coexistence/A-State-Dynamic-Model-Of-Coexistence-Madhyasth-Darshan.pptx
+++ b/Studies/A-State-Dynamic-Model-Of-Coexistence/A-State-Dynamic-Model-Of-Coexistence-Madhyasth-Darshan.pptx
@@ -1230,7 +1230,7 @@
           </a:p>
           <a:p>
             <a:r>
-              <a:t>- Study §7.5</a:t>
+              <a:t>- Study §7.6</a:t>
             </a:r>
           </a:p>
           <a:p>
@@ -1316,7 +1316,7 @@
           </a:p>
           <a:p>
             <a:r>
-              <a:t>- Study §§7.2–7.4, 8.4</a:t>
+              <a:t>- Study §§7.2–7.5, 8.4</a:t>
             </a:r>
           </a:p>
           <a:p>
@@ -1402,7 +1402,7 @@
           </a:p>
           <a:p>
             <a:r>
-              <a:t>- Study §§7.1, 7.4, 7.6</a:t>
+              <a:t>- Study §§7.1, 7.5, 7.7</a:t>
             </a:r>
           </a:p>
           <a:p>
@@ -1574,7 +1574,7 @@
           </a:p>
           <a:p>
             <a:r>
-              <a:t>- Study §§7.7, 10.3</a:t>
+              <a:t>- Study §§7.8, 10.3</a:t>
             </a:r>
           </a:p>
           <a:p>
@@ -1918,7 +1918,7 @@
           </a:p>
           <a:p>
             <a:r>
-              <a:t>- Study §§7.3, 8.3, 11.2</a:t>
+              <a:t>- Study §§7.4, 8.3, 11.2</a:t>
             </a:r>
           </a:p>
           <a:p>

</xml_diff>